<commit_message>
ISTSS decks: precise prevalence labels (crude vs model-predicted) with Stata commands; scripts updated
Co-Authored-By: Claude Opus 5.5 <noreply@anthropic.com>
Claude-Session: https://claude.ai/code/session_019BJ4u1WYcsA14q2B552n7R
</commit_message>
<xml_diff>
--- a/projects/marvin-stress-trauma/istss_mohammed_STROBE.pptx
+++ b/projects/marvin-stress-trauma/istss_mohammed_STROBE.pptx
@@ -2386,7 +2386,7 @@
           <a:lstStyle/>
           <a:p>
             <a:r>
-              <a:t>First, the main effect, so the interaction has context. At zero stressors, adjusted PTSD prevalence rises from about 7 percent among people with no trauma to about 40 percent at five events. Trauma dominates the risk landscape. That part is expected. The question is what happens to the stress gradient along the way.</a:t>
+              <a:t>First, the main effect, so the interaction has context. At zero stressors, model-predicted PTSD prevalence rises from about 7 percent among people with no trauma to about 40 percent at five events. Trauma dominates the risk landscape. These are predicted prevalences from the Poisson model using Stata's margins: each person's probability is predicted at a fixed trauma and stressor level, keeping their own age, gender, education, and state, and the predictions are averaged. That standardizes the comparison to the same covariate mix. The gradient itself is expected. The question is what happens to the stress gradient along the way.</a:t>
             </a:r>
           </a:p>
         </p:txBody>
@@ -2541,7 +2541,7 @@
           <a:lstStyle/>
           <a:p>
             <a:r>
-              <a:t>A sceptic would say the ratio fades only because people with heavy trauma already have high prevalence. So here is the same comparison in percentage points. Going from zero to four stressors adds about 22 points of PTSD prevalence among people with no trauma exposure, 24 points of depression, and 18 points of anxiety. Among people with five or more events, the same four stressors add nothing measurable to any of the three. The fading appears in percentage points too, so it is not an artifact of the ratio scale.</a:t>
+              <a:t>A sceptic would say the ratio fades only because people with heavy trauma already have high prevalence. So here is the same comparison in percentage points, as differences in model-predicted prevalence estimated with margins contrasts. Going from zero to four stressors adds about 22 points of PTSD prevalence among people with no trauma exposure, 24 points of depression, and 18 points of anxiety. Among people with five or more events, the same four stressors add nothing measurable to any of the three. The fading appears in percentage points too, so it is not an artifact of the ratio scale.</a:t>
             </a:r>
           </a:p>
         </p:txBody>
@@ -2674,7 +2674,7 @@
           <a:lstStyle/>
           <a:p>
             <a:r>
-              <a:t>Here is the same result as prevalence. Each line is a level of trauma. The red line, no trauma exposure, rises from about 7 percent to 28 percent across four stressors and keeps climbing. Each step up in trauma rotates the line flatter, and at five or more events the line is high and does not rise with stress; if anything it drifts down. The gradient belongs to people with little trauma; the burden belongs to people with a lot. Depression and anxiety fan out the same way.</a:t>
+              <a:t>Here is the same result as model-predicted prevalence. Each line is a level of trauma. The red line, no trauma exposure, rises from about 7 percent to 28 percent across four stressors and keeps climbing. Each step up in trauma rotates the line flatter, and at five or more events the line is high and does not rise with stress; if anything it drifts down. The gradient belongs to people with little trauma; the burden belongs to people with a lot. Depression and anxiety fan out the same way.</a:t>
             </a:r>
           </a:p>
         </p:txBody>
@@ -9232,7 +9232,7 @@
             </a:pPr>
             <a:r>
               <a:rPr lang="en-US" sz="2000" dirty="0"/>
-              <a:t>Both scales: per-stressor prevalence ratios AND absolute prevalence differences (margins)</a:t>
+              <a:t>Both scales: per-stressor prevalence ratios AND absolute differences in model-predicted prevalence (Stata margins: predictions at fixed trauma and stressor values, averaged over each participant's own covariates)</a:t>
             </a:r>
           </a:p>
           <a:p>
@@ -10822,7 +10822,7 @@
                   <a:srgbClr val="D9D9D9"/>
                 </a:solidFill>
               </a:rPr>
-              <a:t>Outcome Data: PTSD by Trauma Exposure</a:t>
+              <a:t>Outcome Data: PTSD by Trauma</a:t>
             </a:r>
             <a:endParaRPr lang="en-US" dirty="0"/>
           </a:p>
@@ -10870,6 +10870,14 @@
               </a:lnSpc>
               <a:buNone/>
             </a:pPr>
+            <a:r>
+              <a:rPr sz="1300">
+                <a:solidFill>
+                  <a:srgbClr val="FFFFFF"/>
+                </a:solidFill>
+              </a:rPr>
+              <a:t>Model-predicted PTSD prevalence at zero stressors, standardized to sample covariates (Stata margins)</a:t>
+            </a:r>
             <a:endParaRPr lang="en-US" sz="1600" dirty="0">
               <a:solidFill>
                 <a:srgbClr val="D9D9D9"/>
@@ -11675,7 +11683,7 @@
                   <a:srgbClr val="D9D9D9"/>
                 </a:solidFill>
               </a:rPr>
-              <a:t>Change in prevalence per four additional stressors, percentage points (bars: 95% CI)</a:t>
+              <a:t>Change in model-predicted prevalence, 0 → 4 stressors, percentage points (Stata margins; 95% CI)</a:t>
             </a:r>
           </a:p>
         </p:txBody>
@@ -13532,7 +13540,7 @@
                   <a:srgbClr val="D9D9D9"/>
                 </a:solidFill>
               </a:rPr>
-              <a:t>Prevalence (%) by stressor count, at four levels of trauma exposure</a:t>
+              <a:t>Model-predicted prevalence (%) by stressor count, at four levels of trauma exposure (Stata margins)</a:t>
             </a:r>
           </a:p>
         </p:txBody>

</xml_diff>